<commit_message>
Update exercises and resources for GPO workshop, including file name changes and content adjustments
</commit_message>
<xml_diff>
--- a/files/CPALL_Lab_PPT_Executive_Update_Template.pptx
+++ b/files/CPALL_Lab_PPT_Executive_Update_Template.pptx
@@ -23263,7 +23263,7 @@
           <a:p>
             <a:r>
               <a:rPr lang="en-US"/>
-              <a:t>สรุปผลการปฏิบัติการศูนย์กระจายสินค้า (Executive Update Template)</a:t>
+              <a:t>สรุปผลความต่อเนื่องการผลิตและกระจายยา GPO (Executive Update Template)</a:t>
             </a:r>
           </a:p>
         </p:txBody>
@@ -23329,7 +23329,7 @@
           <a:p>
             <a:r>
               <a:rPr lang="en-US"/>
-              <a:t>ข้อมูลสำคัญเกี่ยวกับประสิทธิภาพและความคืบหน้า</a:t>
+              <a:t>ข้อมูลสำคัญด้านคุณภาพ การผลิต และการส่งมอบยา</a:t>
             </a:r>
           </a:p>
         </p:txBody>
@@ -23830,7 +23830,7 @@
               <a:buNone/>
             </a:pPr>
             <a:r>
-              <a:t>เพิ่มจุดสแกนและรถขนส่งสำรอง พร้อมทำ 5S เพื่อเสริมมาตรการความปลอดภัยในโซนคัดแยก</a:t>
+              <a:t>เพิ่มรอบปล่อยล็อต QA จัดรถควบคุมอุณหภูมิสำรอง และทำ 5S เพื่อเสริมความปลอดภัยในโซนแพ็กยา</a:t>
             </a:r>
             <a:endParaRPr lang="th-TH"/>
           </a:p>
@@ -24297,7 +24297,7 @@
             </a:pPr>
             <a:r>
               <a:rPr lang="th-TH" sz="1400"/>
-              <a:t>รวมถึงการอนุมัติรถขนส่งสำรอง งบประมาณอุปกรณ์สแกน และแคมเปญความปลอดภัยในคลังสินค้า</a:t>
+              <a:t>รวมถึงการอนุมัติรถควบคุมอุณหภูมิสำรอง งบประมาณจุดตรวจเอกสาร และมาตรการความปลอดภัยในคลังยา</a:t>
             </a:r>
           </a:p>
           <a:p>
@@ -24648,7 +24648,7 @@
           <a:p>
             <a:r>
               <a:rPr lang="en-US"/>
-              <a:t>ภาพรวมการปฏิบัติการและบริบทสำหรับผู้บริหาร</a:t>
+              <a:t>ภาพรวมการผลิตและกระจายยา สำหรับผู้บริหาร</a:t>
             </a:r>
           </a:p>
         </p:txBody>
@@ -24730,7 +24730,7 @@
             </a:pPr>
             <a:r>
               <a:rPr lang="th-TH" b="1"/>
-              <a:t>ภาพรวมศูนย์กระจายสินค้า</a:t>
+              <a:t>ภาพรวมหน่วยงานหลักของ GPO</a:t>
             </a:r>
           </a:p>
           <a:p>
@@ -24739,7 +24739,7 @@
               <a:buNone/>
             </a:pPr>
             <a:r>
-              <a:t>รายงานครอบคลุมการดำเนินงานของศูนย์กระจายสินค้า 4 แห่งสำคัญในห่วงโซ่อุปทานค้าปลีก</a:t>
+              <a:t>รายงานครอบคลุมการทำงานร่วมกันของโรงงาน, QA/QC, คลัง, และขนส่งยา เพื่อความต่อเนื่องในการส่งมอบ</a:t>
             </a:r>
             <a:endParaRPr lang="th-TH"/>
           </a:p>
@@ -24793,7 +24793,7 @@
               <a:buNone/>
             </a:pPr>
             <a:r>
-              <a:t>ข้อมูล KPI เช่น อัตราการส่งตรงเวลาและชั่วโมงแรงงานถูกนำมาใช้สรุปประสิทธิภาพการปฏิบัติการ</a:t>
+              <a:t>ข้อมูล KPI เช่นอัตราปล่อยล็อตตรงเวลา, อัตราส่งมอบยา, และ OT ถูกใช้สรุปประสิทธิภาพการดำเนินงาน</a:t>
             </a:r>
             <a:endParaRPr lang="th-TH"/>
           </a:p>
@@ -25654,7 +25654,7 @@
           <a:p>
             <a:r>
               <a:rPr lang="en-US"/>
-              <a:t>KPI Highlights ของศูนย์กระจายสินค้า</a:t>
+              <a:t>KPI Highlights ด้านการผลิตและกระจายยา</a:t>
             </a:r>
           </a:p>
         </p:txBody>
@@ -25772,7 +25772,7 @@
               <a:buNone/>
             </a:pPr>
             <a:r>
-              <a:t>ตัวชี้วัดหลักรวมถึงจำนวนออเดอร์ อัตราการส่งตรงเวลา อัตราการเติมเต็มสินค้า และชั่วโมง OT รวม</a:t>
+              <a:t>ตัวชี้วัดหลักรวมถึงจำนวนคำสั่งซื้อจากโรงพยาบาล, อัตราส่งมอบตรงเวลา, Fill rate และชั่วโมง OT รวม</a:t>
             </a:r>
             <a:endParaRPr lang="th-TH"/>
           </a:p>
@@ -25795,7 +25795,7 @@
               <a:buNone/>
             </a:pPr>
             <a:r>
-              <a:t>การเปรียบเทียบ KPI ระหว่างศูนย์ช่วยระบุปัญหาคอขวดและการวางแผนทรัพยากรที่ต้องปรับปรุง</a:t>
+              <a:t>การเปรียบเทียบ KPI ระหว่างฝ่ายช่วยระบุคอขวด เช่นการปล่อยล็อต QA และการจัดรถควบคุมอุณหภูมิ</a:t>
             </a:r>
             <a:endParaRPr lang="th-TH"/>
           </a:p>
@@ -26139,7 +26139,7 @@
           <a:p>
             <a:r>
               <a:rPr lang="en-US"/>
-              <a:t>Issues และ Root Causes ที่ส่งผลต่อการปฏิบัติการ</a:t>
+              <a:t>Issues และ Root Causes ที่ส่งผลต่อการผลิตและการส่งมอบยา</a:t>
             </a:r>
           </a:p>
         </p:txBody>
@@ -26261,7 +26261,7 @@
               <a:buNone/>
             </a:pPr>
             <a:r>
-              <a:t>การส่งของล่าช้าของ DC-บางบัวทองและ Fill rate ลดลงของ DC-เชียงใหม่เกิดจากปัจจัยที่แตกต่างกันเช่นขาดแคลนรถและ lead time ที่ยืดออก</a:t>
+              <a:t>การส่งมอบยาล่าช้าและ Fill rate ลดลง เกิดจากการปล่อยล็อต QA ช้ากว่าปกติและ lead time วัตถุดิบยืดออก</a:t>
             </a:r>
             <a:endParaRPr lang="th-TH"/>
           </a:p>
@@ -26284,7 +26284,7 @@
               <a:buNone/>
             </a:pPr>
             <a:r>
-              <a:t>ปัญหา near-miss และ incident จากการใช้รถโฟล์คลิฟต์ในพื้นที่คับแคบเป็นความเสี่ยงที่ต้องจัดการอย่างเข้มงวด</a:t>
+              <a:t>ปัญหา near-miss และ incident ในโซนแพ็กยาเป็นความเสี่ยงที่ต้องจัดการอย่างเข้มงวด</a:t>
             </a:r>
             <a:endParaRPr lang="th-TH"/>
           </a:p>

</xml_diff>